<commit_message>
Cambio en diapositiva y dev containers para IntelliJ
</commit_message>
<xml_diff>
--- a/docs/tema0/diapositivas/04-programacion-funcional.pptx
+++ b/docs/tema0/diapositivas/04-programacion-funcional.pptx
@@ -4160,7 +4160,7 @@
               <a:buNone/>
             </a:pPr>
             <a:r>
-              <a:rPr lang="en-US" sz="1600" b="1" dirty="0">
+              <a:rPr lang="en-US" sz="1600" b="1">
                 <a:solidFill>
                   <a:srgbClr val="212121"/>
                 </a:solidFill>
@@ -4168,7 +4168,18 @@
                 <a:ea typeface="Arial" pitchFamily="34" charset="-122"/>
                 <a:cs typeface="Arial" pitchFamily="34" charset="-120"/>
               </a:rPr>
-              <a:t>collect() → convierte el resultado en una lista</a:t>
+              <a:t>toList() </a:t>
+            </a:r>
+            <a:r>
+              <a:rPr lang="en-US" sz="1600" b="1" dirty="0">
+                <a:solidFill>
+                  <a:srgbClr val="212121"/>
+                </a:solidFill>
+                <a:latin typeface="Arial" pitchFamily="34" charset="0"/>
+                <a:ea typeface="Arial" pitchFamily="34" charset="-122"/>
+                <a:cs typeface="Arial" pitchFamily="34" charset="-120"/>
+              </a:rPr>
+              <a:t>→ convierte el resultado en una lista</a:t>
             </a:r>
             <a:endParaRPr lang="en-US" sz="1600" dirty="0"/>
           </a:p>

</xml_diff>